<commit_message>
fix(ci): remove npm ci do build (projeto sem dependencias, evita travar)
O npm ci ficava lento/preso no Jenkins Windows (tenta escrever node_modules
no volume montado e/ou faz audit de rede). Como o projeto nao tem
dependencias, o build passa a ser apenas 'npm run check' (a compilacao/
validacao de sintaxe). Atualiza docs e slides.
</commit_message>
<xml_diff>
--- a/slides/jenkins-docker.pptx
+++ b/slides/jenkins-docker.pptx
@@ -7007,7 +7007,7 @@
                 <a:ea typeface="Calibri" pitchFamily="34" charset="-122"/>
                 <a:cs typeface="Calibri" pitchFamily="34" charset="-120"/>
               </a:rPr>
-              <a:t>1º docker run: container de BUILD roda npm ci + npm run check</a:t>
+              <a:t>1º docker run: container de BUILD valida a sintaxe (npm run check)</a:t>
             </a:r>
             <a:endParaRPr lang="en-US" sz="1350" dirty="0"/>
           </a:p>
@@ -18930,7 +18930,7 @@
                 <a:ea typeface="Calibri" pitchFamily="34" charset="-122"/>
                 <a:cs typeface="Calibri" pitchFamily="34" charset="-120"/>
               </a:rPr>
-              <a:t>npm ci + npm run check</a:t>
+              <a:t>npm run check</a:t>
             </a:r>
             <a:endParaRPr lang="en-US" sz="1050" dirty="0"/>
           </a:p>
@@ -20081,7 +20081,7 @@
                 <a:ea typeface="Consolas" pitchFamily="34" charset="-122"/>
                 <a:cs typeface="Consolas" pitchFamily="34" charset="-120"/>
               </a:rPr>
-              <a:t>         "npm ci &amp;&amp; npm run check"'
+              <a:t>         "npm run check"'
 </a:t>
             </a:r>
             <a:pPr algn="l" indent="0" marL="0">
@@ -20238,7 +20238,7 @@
                 <a:ea typeface="Consolas" pitchFamily="34" charset="-122"/>
                 <a:cs typeface="Consolas" pitchFamily="34" charset="-120"/>
               </a:rPr>
-              <a:t>'docker run --rm -v "%CD%":/app -w /app
+              <a:t>'docker run --name teste-%BUILD_NUMBER%
 </a:t>
             </a:r>
             <a:pPr algn="l" indent="0" marL="0">
@@ -20256,7 +20256,7 @@
                 <a:ea typeface="Consolas" pitchFamily="34" charset="-122"/>
                 <a:cs typeface="Consolas" pitchFamily="34" charset="-120"/>
               </a:rPr>
-              <a:t>           node:22-alpine sh -c
+              <a:t>        -v "%CD%":/app -e REPORTS_DIR=/tmp/reports
 </a:t>
             </a:r>
             <a:pPr algn="l" indent="0" marL="0">
@@ -20274,7 +20274,7 @@
                 <a:ea typeface="Consolas" pitchFamily="34" charset="-122"/>
                 <a:cs typeface="Consolas" pitchFamily="34" charset="-120"/>
               </a:rPr>
-              <a:t>           "npm run test:coverage"'
+              <a:t>        node:22-alpine sh -c "npm run test:coverage"'
 </a:t>
             </a:r>
             <a:pPr algn="l" indent="0" marL="0">
@@ -20293,6 +20293,75 @@
                 <a:cs typeface="Consolas" pitchFamily="34" charset="-120"/>
               </a:rPr>
               <a:t>    }
+</a:t>
+            </a:r>
+            <a:pPr algn="l" indent="0" marL="0">
+              <a:lnSpc>
+                <a:spcPct val="112000"/>
+              </a:lnSpc>
+              <a:buNone/>
+            </a:pPr>
+            <a:r>
+              <a:rPr lang="en-US" sz="1100" dirty="0">
+                <a:solidFill>
+                  <a:srgbClr val="BC8CFF"/>
+                </a:solidFill>
+                <a:latin typeface="Consolas" pitchFamily="34" charset="0"/>
+                <a:ea typeface="Consolas" pitchFamily="34" charset="-122"/>
+                <a:cs typeface="Consolas" pitchFamily="34" charset="-120"/>
+              </a:rPr>
+              <a:t>    bat </a:t>
+            </a:r>
+            <a:pPr algn="l" indent="0" marL="0">
+              <a:lnSpc>
+                <a:spcPct val="112000"/>
+              </a:lnSpc>
+              <a:buNone/>
+            </a:pPr>
+            <a:r>
+              <a:rPr lang="en-US" sz="1100" dirty="0">
+                <a:solidFill>
+                  <a:srgbClr val="3FB950"/>
+                </a:solidFill>
+                <a:latin typeface="Consolas" pitchFamily="34" charset="0"/>
+                <a:ea typeface="Consolas" pitchFamily="34" charset="-122"/>
+                <a:cs typeface="Consolas" pitchFamily="34" charset="-120"/>
+              </a:rPr>
+              <a:t>'docker cp teste-..:/tmp/reports reports'</a:t>
+            </a:r>
+            <a:pPr algn="l" indent="0" marL="0">
+              <a:lnSpc>
+                <a:spcPct val="112000"/>
+              </a:lnSpc>
+              <a:buNone/>
+            </a:pPr>
+            <a:r>
+              <a:rPr lang="en-US" sz="1100" dirty="0">
+                <a:solidFill>
+                  <a:srgbClr val="E6EDF3"/>
+                </a:solidFill>
+                <a:latin typeface="Consolas" pitchFamily="34" charset="0"/>
+                <a:ea typeface="Consolas" pitchFamily="34" charset="-122"/>
+                <a:cs typeface="Consolas" pitchFamily="34" charset="-120"/>
+              </a:rPr>
+              <a:t>  </a:t>
+            </a:r>
+            <a:pPr algn="l" indent="0" marL="0">
+              <a:lnSpc>
+                <a:spcPct val="112000"/>
+              </a:lnSpc>
+              <a:buNone/>
+            </a:pPr>
+            <a:r>
+              <a:rPr lang="en-US" sz="1100" dirty="0">
+                <a:solidFill>
+                  <a:srgbClr val="8B949E"/>
+                </a:solidFill>
+                <a:latin typeface="Consolas" pitchFamily="34" charset="0"/>
+                <a:ea typeface="Consolas" pitchFamily="34" charset="-122"/>
+                <a:cs typeface="Consolas" pitchFamily="34" charset="-120"/>
+              </a:rPr>
+              <a:t>// EACCES
 </a:t>
             </a:r>
             <a:pPr algn="l" indent="0" marL="0">

</xml_diff>